<commit_message>
docs: finalize day 03 course materials
</commit_message>
<xml_diff>
--- a/course/day-03/slides/day-03-generative-ai-text-analysis.pptx
+++ b/course/day-03/slides/day-03-generative-ai-text-analysis.pptx
@@ -4607,7 +4607,7 @@
                 <a:ea typeface="Microsoft JhengHei" panose="020B0604030504040204" pitchFamily="34" charset="-120"/>
                 <a:cs typeface="Noto Sans TC" pitchFamily="34" charset="-120"/>
               </a:rPr>
-              <a:t>每段都不能失去 document_id、source_url、crawled_at。</a:t>
+              <a:t>提示詞 03：只處理 ready_for_analysis；每段保留來源章節、URL 與時間。</a:t>
             </a:r>
             <a:endParaRPr lang="en-US" sz="1800" dirty="0">
               <a:latin typeface="Microsoft JhengHei" panose="020B0604030504040204" pitchFamily="34" charset="-120"/>
@@ -4733,7 +4733,7 @@
                 <a:latin typeface="Microsoft JhengHei"/>
                 <a:ea typeface="Microsoft JhengHei"/>
               </a:rPr>
-              <a:t>文本分析｜analysis/text_analysis.jsonl：證據與解讀分欄</a:t>
+              <a:t>文本分析｜analysis/text_analysis.md：證據與解讀分欄</a:t>
             </a:r>
             <a:endParaRPr lang="en-US" sz="3000"/>
           </a:p>
@@ -6059,7 +6059,7 @@
                 <a:latin typeface="Microsoft JhengHei"/>
                 <a:ea typeface="Microsoft JhengHei"/>
               </a:rPr>
-              <a:t>schema</a:t>
+              <a:t>分析表欄位</a:t>
             </a:r>
             <a:r>
               <a:rPr lang="zh-TW" altLang="en-US" sz="1100">
@@ -6079,7 +6079,7 @@
                 <a:latin typeface="Microsoft JhengHei"/>
                 <a:ea typeface="Microsoft JhengHei"/>
               </a:rPr>
-              <a:t>document_id · chunk_id · summary · category · document_evidence · ai_interpretation</a:t>
+              <a:t>八欄：document_id · chunk_id · summary · category · administrative_information · topic · document_evidence · ai_interpretation</a:t>
             </a:r>
             <a:endParaRPr lang="zh-TW" altLang="en-US" sz="1100">
               <a:solidFill>
@@ -6799,7 +6799,7 @@
                 <a:ea typeface="Microsoft JhengHei" panose="020B0604030504040204" pitchFamily="34" charset="-120"/>
                 <a:cs typeface="Noto Sans TC" pitchFamily="34" charset="-120"/>
               </a:rPr>
-              <a:t>Ollama</a:t>
+              <a:t>Ollama 回答模型</a:t>
             </a:r>
             <a:endParaRPr lang="en-US" sz="1400" dirty="0">
               <a:latin typeface="Microsoft JhengHei" panose="020B0604030504040204" pitchFamily="34" charset="-120"/>
@@ -7159,7 +7159,7 @@
                 <a:latin typeface="Microsoft JhengHei"/>
                 <a:ea typeface="Microsoft JhengHei"/>
               </a:rPr>
-              <a:t>rag/citations.jsonl  schema</a:t>
+              <a:t>提示詞 04：最多三筆；不足證據不呼叫模型。</a:t>
             </a:r>
             <a:r>
               <a:rPr lang="zh-TW" altLang="en-US" sz="1100">
@@ -7169,7 +7169,7 @@
                 <a:latin typeface="Microsoft JhengHei"/>
                 <a:ea typeface="Microsoft JhengHei"/>
               </a:rPr>
-              <a:t>：</a:t>
+              <a:t/>
             </a:r>
             <a:r>
               <a:rPr lang="en-US" altLang="zh-TW" sz="1100">
@@ -7179,7 +7179,7 @@
                 <a:latin typeface="Microsoft JhengHei"/>
                 <a:ea typeface="Microsoft JhengHei"/>
               </a:rPr>
-              <a:t>query_id · document_id · chunk_id · source_url · locator · crawled_at</a:t>
+              <a:t>顯示：status · chunks · scores · 文件 · URL · 段落 · crawled_at</a:t>
             </a:r>
             <a:endParaRPr lang="zh-TW" altLang="en-US" sz="1100">
               <a:solidFill>
@@ -8936,7 +8936,7 @@
                 <a:latin typeface="Microsoft JhengHei"/>
                 <a:ea typeface="Microsoft JhengHei"/>
               </a:rPr>
-              <a:t>Step 05｜feedback/query_log.jsonl：每次問答都留下改善訊號</a:t>
+              <a:t>Step 05｜問答歷程：每次問答都留下改善訊號</a:t>
             </a:r>
             <a:endParaRPr lang="en-US" sz="3000"/>
           </a:p>
@@ -9270,7 +9270,7 @@
                 <a:ea typeface="Microsoft JhengHei" panose="020B0604030504040204" pitchFamily="34" charset="-120"/>
                 <a:cs typeface="Noto Sans TC" pitchFamily="34" charset="-120"/>
               </a:rPr>
-              <a:t>answer_status</a:t>
+              <a:t>answer／status</a:t>
             </a:r>
             <a:endParaRPr lang="en-US" sz="1400" dirty="0">
               <a:latin typeface="Microsoft JhengHei" panose="020B0604030504040204" pitchFamily="34" charset="-120"/>
@@ -9426,7 +9426,7 @@
                 <a:ea typeface="Microsoft JhengHei" panose="020B0604030504040204" pitchFamily="34" charset="-120"/>
                 <a:cs typeface="Noto Sans TC" pitchFamily="34" charset="-120"/>
               </a:rPr>
-              <a:t>user_feedback</a:t>
+              <a:t>self_test_note</a:t>
             </a:r>
             <a:endParaRPr lang="en-US" sz="1400" dirty="0">
               <a:latin typeface="Microsoft JhengHei" panose="020B0604030504040204" pitchFamily="34" charset="-120"/>
@@ -9654,7 +9654,7 @@
                 <a:ea typeface="Microsoft JhengHei" panose="020B0604030504040204" pitchFamily="34" charset="-120"/>
                 <a:cs typeface="Noto Sans TC" pitchFamily="34" charset="-120"/>
               </a:rPr>
-              <a:t>insufficient_evidence</a:t>
+              <a:t>不足證據</a:t>
             </a:r>
             <a:endParaRPr lang="en-US" sz="1400" dirty="0">
               <a:latin typeface="Microsoft JhengHei" panose="020B0604030504040204" pitchFamily="34" charset="-120"/>
@@ -9806,7 +9806,7 @@
                 <a:ea typeface="Microsoft JhengHei" panose="020B0604030504040204" pitchFamily="34" charset="-120"/>
                 <a:cs typeface="Noto Sans TC" pitchFamily="34" charset="-120"/>
               </a:rPr>
-              <a:t>null</a:t>
+              <a:t>缺少資格考規章</a:t>
             </a:r>
             <a:endParaRPr lang="en-US" sz="1400" dirty="0">
               <a:latin typeface="Microsoft JhengHei" panose="020B0604030504040204" pitchFamily="34" charset="-120"/>
@@ -9850,7 +9850,7 @@
                 <a:ea typeface="Microsoft JhengHei" panose="020B0604030504040204" pitchFamily="34" charset="-120"/>
                 <a:cs typeface="Noto Sans TC" pitchFamily="34" charset="-120"/>
               </a:rPr>
-              <a:t>JSONL：每行一筆紀錄，方便追加、分類與分析。</a:t>
+              <a:t>提示詞 05：從 query_log 產出可回連的改善 backlog。</a:t>
             </a:r>
             <a:endParaRPr lang="en-US" sz="1800" dirty="0">
               <a:latin typeface="Microsoft JhengHei" panose="020B0604030504040204" pitchFamily="34" charset="-120"/>
@@ -9976,7 +9976,7 @@
                 <a:latin typeface="Microsoft JhengHei"/>
                 <a:ea typeface="Microsoft JhengHei"/>
               </a:rPr>
-              <a:t>改善 backlog｜feedback/improvement_backlog.jsonl</a:t>
+              <a:t>改善 backlog｜feedback/improvement_backlog.md</a:t>
             </a:r>
             <a:endParaRPr lang="en-US" sz="3000"/>
           </a:p>
@@ -10415,7 +10415,7 @@
                 <a:latin typeface="Microsoft JhengHei"/>
                 <a:ea typeface="Microsoft JhengHei"/>
               </a:rPr>
-              <a:t>source_query_ids</a:t>
+              <a:t>query_id</a:t>
             </a:r>
           </a:p>
           <a:p>
@@ -10847,7 +10847,7 @@
                 <a:ea typeface="Microsoft JhengHei" panose="020B0604030504040204" pitchFamily="34" charset="-120"/>
                 <a:cs typeface="Noto Sans TC" pitchFamily="34" charset="-120"/>
               </a:rPr>
-              <a:t>add_source</a:t>
+              <a:t>五種允許動作</a:t>
             </a:r>
             <a:endParaRPr lang="en-US" sz="1500" dirty="0">
               <a:latin typeface="Microsoft JhengHei" panose="020B0604030504040204" pitchFamily="34" charset="-120"/>
@@ -10867,7 +10867,7 @@
                 <a:ea typeface="Microsoft JhengHei" panose="020B0604030504040204" pitchFamily="34" charset="-120"/>
                 <a:cs typeface="Noto Sans TC" pitchFamily="34" charset="-120"/>
               </a:rPr>
-              <a:t>repair_parse</a:t>
+              <a:t>擇一執行</a:t>
             </a:r>
             <a:endParaRPr lang="en-US" sz="1500" dirty="0">
               <a:latin typeface="Microsoft JhengHei" panose="020B0604030504040204" pitchFamily="34" charset="-120"/>
@@ -10966,7 +10966,7 @@
                 <a:latin typeface="Microsoft JhengHei"/>
                 <a:ea typeface="Microsoft JhengHei"/>
               </a:rPr>
-              <a:t>schema</a:t>
+              <a:t>每項至少包含</a:t>
             </a:r>
             <a:r>
               <a:rPr lang="zh-TW" altLang="en-US" sz="1100">
@@ -10986,7 +10986,7 @@
                 <a:latin typeface="Microsoft JhengHei"/>
                 <a:ea typeface="Microsoft JhengHei"/>
               </a:rPr>
-              <a:t>backlog_id · phenomenon · evidence · cause · action · source_query_ids · priority · status</a:t>
+              <a:t>add_source · repair_parse · revise_chunking_or_metadata · improve_retrieval · revise_prompt</a:t>
             </a:r>
             <a:endParaRPr lang="zh-TW" altLang="en-US" sz="1100">
               <a:solidFill>
@@ -11063,7 +11063,7 @@
                 <a:ea typeface="Microsoft JhengHei" panose="020B0604030504040204" pitchFamily="34" charset="-120"/>
                 <a:cs typeface="Noto Sans TC" pitchFamily="34" charset="-120"/>
               </a:rPr>
-              <a:t>最後繳交：五個可驗證的成果</a:t>
+              <a:t>自我完成檢核：五個可驗證的成果</a:t>
             </a:r>
             <a:endParaRPr lang="en-US" sz="3200" dirty="0">
               <a:latin typeface="Microsoft JhengHei" panose="020B0604030504040204" pitchFamily="34" charset="-120"/>
@@ -11629,7 +11629,7 @@
                 <a:latin typeface="Microsoft JhengHei"/>
                 <a:ea typeface="Microsoft JhengHei"/>
               </a:rPr>
-              <a:t>chunks.jsonl · text_analysis.jsonl</a:t>
+              <a:t>chunks.jsonl · text_analysis.md</a:t>
             </a:r>
             <a:endParaRPr lang="en-US" sz="1000"/>
           </a:p>
@@ -11750,7 +11750,7 @@
                 <a:ea typeface="Microsoft JhengHei" panose="020B0604030504040204" pitchFamily="34" charset="-120"/>
                 <a:cs typeface="Noto Sans TC" pitchFamily="34" charset="-120"/>
               </a:rPr>
-              <a:t>可引用問答</a:t>
+              <a:t>可引用問答＋歷程</a:t>
             </a:r>
             <a:endParaRPr lang="en-US" sz="1550" dirty="0">
               <a:latin typeface="Microsoft JhengHei" panose="020B0604030504040204" pitchFamily="34" charset="-120"/>
@@ -11793,7 +11793,7 @@
                 <a:latin typeface="Microsoft JhengHei"/>
                 <a:ea typeface="Microsoft JhengHei"/>
               </a:rPr>
-              <a:t>Streamlit · citations.jsonl</a:t>
+              <a:t>Streamlit · 問答＋歷程</a:t>
             </a:r>
           </a:p>
           <a:p>
@@ -11972,7 +11972,7 @@
                 <a:latin typeface="Microsoft JhengHei"/>
                 <a:ea typeface="Microsoft JhengHei"/>
               </a:rPr>
-              <a:t>improvement_backlog.jsonl</a:t>
+              <a:t>improvement_backlog.md</a:t>
             </a:r>
           </a:p>
           <a:p>
@@ -11987,7 +11987,7 @@
                 <a:latin typeface="Microsoft JhengHei"/>
                 <a:ea typeface="Microsoft JhengHei"/>
               </a:rPr>
-              <a:t>含原因 · source_query_ids</a:t>
+              <a:t>含原因 · query_id</a:t>
             </a:r>
             <a:endParaRPr lang="en-US" sz="850"/>
           </a:p>
@@ -12028,7 +12028,7 @@
                 <a:ea typeface="Microsoft JhengHei" panose="020B0604030504040204" pitchFamily="34" charset="-120"/>
                 <a:cs typeface="Noto Sans TC" pitchFamily="34" charset="-120"/>
               </a:rPr>
-              <a:t>評量重點：資料可追溯性與改善判斷，不是聊天介面多漂亮。</a:t>
+              <a:t>重點：在自己電腦完成完整證據鏈；不收件、不評分。</a:t>
             </a:r>
             <a:endParaRPr lang="en-US" sz="2000" dirty="0">
               <a:latin typeface="Microsoft JhengHei" panose="020B0604030504040204" pitchFamily="34" charset="-120"/>
@@ -12920,7 +12920,7 @@
                 <a:ea typeface="Microsoft JhengHei" panose="020B0604030504040204" pitchFamily="34" charset="-120"/>
                 <a:cs typeface="Noto Sans TC" pitchFamily="34" charset="-120"/>
               </a:rPr>
-              <a:t>用互動資料改善</a:t>
+              <a:t>用自我測試改善</a:t>
             </a:r>
             <a:endParaRPr lang="en-US" sz="1500" dirty="0">
               <a:latin typeface="Microsoft JhengHei" panose="020B0604030504040204" pitchFamily="34" charset="-120"/>
@@ -12961,7 +12961,7 @@
                 <a:ea typeface="Microsoft JhengHei" panose="020B0604030504040204" pitchFamily="34" charset="-120"/>
                 <a:cs typeface="Noto Sans TC" pitchFamily="34" charset="-120"/>
               </a:rPr>
-              <a:t>資料 → 文本 → AI 分析 → 智慧應用 → 使用者回饋 → 系統改善</a:t>
+              <a:t>資料 → 文本 → AI 分析 → 可引用問答 → 自我測試 → 系統改善</a:t>
             </a:r>
             <a:endParaRPr lang="en-US" sz="2000" dirty="0">
               <a:latin typeface="Microsoft JhengHei" panose="020B0604030504040204" pitchFamily="34" charset="-120"/>
@@ -15841,7 +15841,7 @@
                 <a:ea typeface="Microsoft JhengHei" panose="020B0604030504040204" pitchFamily="34" charset="-120"/>
                 <a:cs typeface="Noto Sans TC" pitchFamily="34" charset="-120"/>
               </a:rPr>
-              <a:t>Step 00｜先建立小組專案，再確認資料範圍</a:t>
+              <a:t>Step 00｜建立個人專案與固定資料範圍</a:t>
             </a:r>
             <a:endParaRPr lang="en-US" sz="3200" dirty="0">
               <a:latin typeface="Microsoft JhengHei" panose="020B0604030504040204" pitchFamily="34" charset="-120"/>
@@ -16020,7 +16020,7 @@
                 <a:ea typeface="Microsoft JhengHei" panose="020B0604030504040204" pitchFamily="34" charset="-120"/>
                 <a:cs typeface="Noto Sans TC" pitchFamily="34" charset="-120"/>
               </a:rPr>
-              <a:t>現在要做什麼？</a:t>
+              <a:t>提示詞 00｜可貼給 Codex</a:t>
             </a:r>
             <a:endParaRPr lang="en-US" sz="2000" dirty="0">
               <a:latin typeface="Microsoft JhengHei" panose="020B0604030504040204" pitchFamily="34" charset="-120"/>
@@ -16064,7 +16064,7 @@
                 <a:ea typeface="Microsoft JhengHei" panose="020B0604030504040204" pitchFamily="34" charset="-120"/>
                 <a:cs typeface="Noto Sans TC" pitchFamily="34" charset="-120"/>
               </a:rPr>
-              <a:t>1. 建立 team-xx-project/</a:t>
+              <a:t>1. 建立自訂名稱的個人專案資料夾</a:t>
             </a:r>
             <a:endParaRPr lang="en-US" sz="1600" dirty="0">
               <a:latin typeface="Microsoft JhengHei" panose="020B0604030504040204" pitchFamily="34" charset="-120"/>
@@ -16084,7 +16084,7 @@
                 <a:ea typeface="Microsoft JhengHei" panose="020B0604030504040204" pitchFamily="34" charset="-120"/>
                 <a:cs typeface="Noto Sans TC" pitchFamily="34" charset="-120"/>
               </a:rPr>
-              <a:t>2. 填入講師指定起始網址</a:t>
+              <a:t>2. 填入統一起始網址</a:t>
             </a:r>
             <a:endParaRPr lang="en-US" sz="1600" dirty="0">
               <a:latin typeface="Microsoft JhengHei" panose="020B0604030504040204" pitchFamily="34" charset="-120"/>
@@ -16104,7 +16104,7 @@
                 <a:ea typeface="Microsoft JhengHei" panose="020B0604030504040204" pitchFamily="34" charset="-120"/>
                 <a:cs typeface="Noto Sans TC" pitchFamily="34" charset="-120"/>
               </a:rPr>
-              <a:t>3. 提出 allowed_hosts、允許路徑、格式與數量上限</a:t>
+              <a:t>3. 寫入固定 host、路徑、格式與數量上限</a:t>
             </a:r>
             <a:endParaRPr lang="en-US" sz="1600" dirty="0">
               <a:latin typeface="Microsoft JhengHei" panose="020B0604030504040204" pitchFamily="34" charset="-120"/>
@@ -16124,7 +16124,7 @@
                 <a:ea typeface="Microsoft JhengHei" panose="020B0604030504040204" pitchFamily="34" charset="-120"/>
                 <a:cs typeface="Noto Sans TC" pitchFamily="34" charset="-120"/>
               </a:rPr>
-              <a:t>4. 等待確認後才寫 crawl_scope.json</a:t>
+              <a:t>4. 檢核 scope 後才開始爬取</a:t>
             </a:r>
             <a:endParaRPr lang="en-US" sz="1600" dirty="0">
               <a:latin typeface="Microsoft JhengHei" panose="020B0604030504040204" pitchFamily="34" charset="-120"/>
@@ -16248,7 +16248,7 @@
                 <a:ea typeface="Microsoft JhengHei" panose="020B0604030504040204" pitchFamily="34" charset="-120"/>
                 <a:cs typeface="Consolas" pitchFamily="34" charset="-120"/>
               </a:rPr>
-              <a:t>team-01-project/</a:t>
+              <a:t>my-project/</a:t>
             </a:r>
             <a:endParaRPr lang="en-US" sz="1600" dirty="0">
               <a:latin typeface="Microsoft JhengHei" panose="020B0604030504040204" pitchFamily="34" charset="-120"/>
@@ -17731,7 +17731,7 @@
                   <a:ea typeface="Microsoft JhengHei" panose="020B0604030504040204" pitchFamily="34" charset="-120"/>
                   <a:cs typeface="Noto Sans TC" pitchFamily="34" charset="-120"/>
                 </a:rPr>
-                <a:t>讀 scope</a:t>
+                <a:t>提示詞 01｜讀 scope</a:t>
               </a:r>
               <a:endParaRPr lang="en-US" sz="1600" dirty="0">
                 <a:latin typeface="Microsoft JhengHei" panose="020B0604030504040204" pitchFamily="34" charset="-120"/>
@@ -19541,7 +19541,7 @@
                   <a:ea typeface="Microsoft JhengHei" panose="020B0604030504040204" pitchFamily="34" charset="-120"/>
                   <a:cs typeface="Noto Sans TC" pitchFamily="34" charset="-120"/>
                 </a:rPr>
-                <a:t>輸入</a:t>
+                <a:t>提示詞 02｜輸入</a:t>
               </a:r>
               <a:endParaRPr lang="en-US" sz="1800" dirty="0">
                 <a:latin typeface="Microsoft JhengHei" panose="020B0604030504040204" pitchFamily="34" charset="-120"/>
@@ -20953,7 +20953,7 @@
                 <a:latin typeface="Microsoft JhengHei"/>
                 <a:ea typeface="Microsoft JhengHei"/>
               </a:rPr>
-              <a:t>data/processed/quality_report.jsonl  schema</a:t>
+              <a:t>data/markdown/quality_report.jsonl  schema</a:t>
             </a:r>
             <a:r>
               <a:rPr lang="zh-TW" altLang="en-US" sz="1100">
@@ -20973,7 +20973,7 @@
                 <a:latin typeface="Microsoft JhengHei"/>
                 <a:ea typeface="Microsoft JhengHei"/>
               </a:rPr>
-              <a:t>document_id · markdown_path · quality_status · quality_reasons · checked_at · checked_by</a:t>
+              <a:t>document_id · markdown_path · quality_status · checked_features · reason · checked_at</a:t>
             </a:r>
             <a:endParaRPr lang="zh-TW" altLang="en-US" sz="1100">
               <a:solidFill>

</xml_diff>